<commit_message>
feat: complete macOS native PowerPoint render
</commit_message>
<xml_diff>
--- a/powerpoint-native-render/tests/fixtures/one-slide.pptx
+++ b/powerpoint-native-render/tests/fixtures/one-slide.pptx
@@ -440,7 +440,12 @@
         <p:txBody>
           <a:bodyPr xmlns:a="http://schemas.openxmlformats.org/drawingml/2006/main"/>
           <a:lstStyle xmlns:a="http://schemas.openxmlformats.org/drawingml/2006/main"/>
-          <a:p xmlns:a="http://schemas.openxmlformats.org/drawingml/2006/main"/>
+          <a:p xmlns:a="http://schemas.openxmlformats.org/drawingml/2006/main">
+            <a:r>
+              <a:rPr lang="en-US"/>
+              <a:t>SPEAKER_NOTES_MUST_NOT_APPEAR_9F3A</a:t>
+            </a:r>
+          </a:p>
         </p:txBody>
       </p:sp>
       <p:sp>

</xml_diff>